<commit_message>
Exports in the client's templates: call sheets, registers, audio, storyboard deck, timeline by year
- sheet-export.py: call_sheet (one file a day), talents/props/locations
  (landed register rows) and audio (audio.md) as a house-styled sheet; the
  shot list falls back to the house template when the client has none
- timeline-layout.py: lays the twelve-month calendar out for any year
- storyboard-pptx.py: fills the storyboard slide template three panels a
  slide (drawn panel, number, shot size, description, supers, lower 3rd,
  VO/SFX from audio.md); empty places on the last slide cleared
- push-sheet.js accepts the new items and carries call-sheet days
- house storyboard template: frames keep the pictures' stacking order and
  the boxes are named per panel column
- tests: exports.e2e.js

Co-Authored-By: Claude Opus 5.5 <noreply@anthropic.com>
</commit_message>
<xml_diff>
--- a/templates/house/storyboard.pptx
+++ b/templates/house/storyboard.pptx
@@ -5453,888 +5453,6 @@
       </p:grpSpPr>
       <p:sp>
         <p:nvSpPr>
-          <p:cNvPr id="57" name="P1_NUMBER"/>
-          <p:cNvSpPr/>
-          <p:nvPr/>
-        </p:nvSpPr>
-        <p:spPr>
-          <a:xfrm>
-            <a:off x="2780650" y="1549975"/>
-            <a:ext cx="372300" cy="379800"/>
-          </a:xfrm>
-          <a:prstGeom prst="rect">
-            <a:avLst/>
-          </a:prstGeom>
-          <a:solidFill>
-            <a:srgbClr val="00FFFF"/>
-          </a:solidFill>
-          <a:ln>
-            <a:noFill/>
-          </a:ln>
-        </p:spPr>
-        <p:txBody>
-          <a:bodyPr anchorCtr="0" anchor="ctr" bIns="91425" lIns="91425" spcFirstLastPara="1" rIns="91425" wrap="square" tIns="91425">
-            <a:noAutofit/>
-          </a:bodyPr>
-          <a:lstStyle/>
-          <a:p>
-            <a:pPr indent="0" lvl="0" marL="0" rtl="0" algn="ctr">
-              <a:spcBef>
-                <a:spcPts val="0"/>
-              </a:spcBef>
-              <a:spcAft>
-                <a:spcPts val="0"/>
-              </a:spcAft>
-              <a:buNone/>
-            </a:pPr>
-            <a:r>
-              <a:rPr b="1" lang="en" sz="1200"/>
-              <a:t>1</a:t>
-            </a:r>
-            <a:endParaRPr b="1" sz="1200"/>
-          </a:p>
-        </p:txBody>
-      </p:sp>
-      <p:sp>
-        <p:nvSpPr>
-          <p:cNvPr id="58" name="P2_NUMBER"/>
-          <p:cNvSpPr/>
-          <p:nvPr/>
-        </p:nvSpPr>
-        <p:spPr>
-          <a:xfrm>
-            <a:off x="5548250" y="1549975"/>
-            <a:ext cx="372300" cy="379800"/>
-          </a:xfrm>
-          <a:prstGeom prst="rect">
-            <a:avLst/>
-          </a:prstGeom>
-          <a:solidFill>
-            <a:srgbClr val="00FFFF"/>
-          </a:solidFill>
-          <a:ln>
-            <a:noFill/>
-          </a:ln>
-        </p:spPr>
-        <p:txBody>
-          <a:bodyPr anchorCtr="0" anchor="ctr" bIns="91425" lIns="91425" spcFirstLastPara="1" rIns="91425" wrap="square" tIns="91425">
-            <a:noAutofit/>
-          </a:bodyPr>
-          <a:lstStyle/>
-          <a:p>
-            <a:pPr indent="0" lvl="0" marL="0" rtl="0" algn="ctr">
-              <a:spcBef>
-                <a:spcPts val="0"/>
-              </a:spcBef>
-              <a:spcAft>
-                <a:spcPts val="0"/>
-              </a:spcAft>
-              <a:buNone/>
-            </a:pPr>
-            <a:r>
-              <a:rPr b="1" lang="en" sz="1200"/>
-              <a:t>2</a:t>
-            </a:r>
-            <a:endParaRPr b="1" sz="1200"/>
-          </a:p>
-        </p:txBody>
-      </p:sp>
-      <p:sp>
-        <p:nvSpPr>
-          <p:cNvPr id="59" name="P3_NUMBER"/>
-          <p:cNvSpPr/>
-          <p:nvPr/>
-        </p:nvSpPr>
-        <p:spPr>
-          <a:xfrm>
-            <a:off x="8315850" y="1549975"/>
-            <a:ext cx="372300" cy="379800"/>
-          </a:xfrm>
-          <a:prstGeom prst="rect">
-            <a:avLst/>
-          </a:prstGeom>
-          <a:solidFill>
-            <a:srgbClr val="00FFFF"/>
-          </a:solidFill>
-          <a:ln>
-            <a:noFill/>
-          </a:ln>
-        </p:spPr>
-        <p:txBody>
-          <a:bodyPr anchorCtr="0" anchor="ctr" bIns="91425" lIns="91425" spcFirstLastPara="1" rIns="91425" wrap="square" tIns="91425">
-            <a:noAutofit/>
-          </a:bodyPr>
-          <a:lstStyle/>
-          <a:p>
-            <a:pPr indent="0" lvl="0" marL="0" rtl="0" algn="ctr">
-              <a:spcBef>
-                <a:spcPts val="0"/>
-              </a:spcBef>
-              <a:spcAft>
-                <a:spcPts val="0"/>
-              </a:spcAft>
-              <a:buNone/>
-            </a:pPr>
-            <a:r>
-              <a:rPr b="1" lang="en" sz="1200"/>
-              <a:t>3</a:t>
-            </a:r>
-            <a:endParaRPr b="1" sz="1200"/>
-          </a:p>
-        </p:txBody>
-      </p:sp>
-      <p:sp>
-        <p:nvSpPr>
-          <p:cNvPr id="60" name="P2_SHOT_SIZE"/>
-          <p:cNvSpPr/>
-          <p:nvPr/>
-        </p:nvSpPr>
-        <p:spPr>
-          <a:xfrm>
-            <a:off x="455925" y="2096925"/>
-            <a:ext cx="2697000" cy="288600"/>
-          </a:xfrm>
-          <a:prstGeom prst="rect">
-            <a:avLst/>
-          </a:prstGeom>
-          <a:solidFill>
-            <a:schemeClr val="lt2"/>
-          </a:solidFill>
-          <a:ln cap="flat" cmpd="sng" w="9525">
-            <a:solidFill>
-              <a:schemeClr val="dk2"/>
-            </a:solidFill>
-            <a:prstDash val="solid"/>
-            <a:round/>
-            <a:headEnd len="sm" w="sm" type="none"/>
-            <a:tailEnd len="sm" w="sm" type="none"/>
-          </a:ln>
-        </p:spPr>
-        <p:txBody>
-          <a:bodyPr anchorCtr="0" anchor="ctr" bIns="91425" lIns="91425" spcFirstLastPara="1" rIns="91425" wrap="square" tIns="91425">
-            <a:noAutofit/>
-          </a:bodyPr>
-          <a:lstStyle/>
-          <a:p>
-            <a:pPr indent="0" lvl="0" marL="0" rtl="0" algn="ctr">
-              <a:spcBef>
-                <a:spcPts val="0"/>
-              </a:spcBef>
-              <a:spcAft>
-                <a:spcPts val="0"/>
-              </a:spcAft>
-              <a:buNone/>
-            </a:pPr>
-            <a:r>
-              <a:rPr lang="en"/>
-              <a:t>SHOT SIZE</a:t>
-            </a:r>
-            <a:endParaRPr/>
-          </a:p>
-        </p:txBody>
-      </p:sp>
-      <p:sp>
-        <p:nvSpPr>
-          <p:cNvPr id="61" name="P1_SHOT_DESCRIPTION"/>
-          <p:cNvSpPr/>
-          <p:nvPr/>
-        </p:nvSpPr>
-        <p:spPr>
-          <a:xfrm>
-            <a:off x="455900" y="2465400"/>
-            <a:ext cx="2697000" cy="1014300"/>
-          </a:xfrm>
-          <a:prstGeom prst="rect">
-            <a:avLst/>
-          </a:prstGeom>
-          <a:solidFill>
-            <a:schemeClr val="lt2"/>
-          </a:solidFill>
-          <a:ln cap="flat" cmpd="sng" w="9525">
-            <a:solidFill>
-              <a:schemeClr val="dk2"/>
-            </a:solidFill>
-            <a:prstDash val="solid"/>
-            <a:round/>
-            <a:headEnd len="sm" w="sm" type="none"/>
-            <a:tailEnd len="sm" w="sm" type="none"/>
-          </a:ln>
-        </p:spPr>
-        <p:txBody>
-          <a:bodyPr anchorCtr="0" anchor="ctr" bIns="91425" lIns="91425" spcFirstLastPara="1" rIns="91425" wrap="square" tIns="91425">
-            <a:noAutofit/>
-          </a:bodyPr>
-          <a:lstStyle/>
-          <a:p>
-            <a:pPr indent="0" lvl="0" marL="0" rtl="0" algn="ctr">
-              <a:spcBef>
-                <a:spcPts val="0"/>
-              </a:spcBef>
-              <a:spcAft>
-                <a:spcPts val="0"/>
-              </a:spcAft>
-              <a:buNone/>
-            </a:pPr>
-            <a:r>
-              <a:rPr lang="en"/>
-              <a:t>SHOT DESCRIPTION</a:t>
-            </a:r>
-            <a:endParaRPr/>
-          </a:p>
-        </p:txBody>
-      </p:sp>
-      <p:sp>
-        <p:nvSpPr>
-          <p:cNvPr id="62" name="P1_SUPERS"/>
-          <p:cNvSpPr/>
-          <p:nvPr/>
-        </p:nvSpPr>
-        <p:spPr>
-          <a:xfrm>
-            <a:off x="455900" y="3559575"/>
-            <a:ext cx="2697000" cy="288600"/>
-          </a:xfrm>
-          <a:prstGeom prst="rect">
-            <a:avLst/>
-          </a:prstGeom>
-          <a:solidFill>
-            <a:schemeClr val="lt2"/>
-          </a:solidFill>
-          <a:ln cap="flat" cmpd="sng" w="9525">
-            <a:solidFill>
-              <a:schemeClr val="dk2"/>
-            </a:solidFill>
-            <a:prstDash val="solid"/>
-            <a:round/>
-            <a:headEnd len="sm" w="sm" type="none"/>
-            <a:tailEnd len="sm" w="sm" type="none"/>
-          </a:ln>
-        </p:spPr>
-        <p:txBody>
-          <a:bodyPr anchorCtr="0" anchor="ctr" bIns="91425" lIns="91425" spcFirstLastPara="1" rIns="91425" wrap="square" tIns="91425">
-            <a:noAutofit/>
-          </a:bodyPr>
-          <a:lstStyle/>
-          <a:p>
-            <a:pPr indent="0" lvl="0" marL="0" rtl="0" algn="ctr">
-              <a:spcBef>
-                <a:spcPts val="0"/>
-              </a:spcBef>
-              <a:spcAft>
-                <a:spcPts val="0"/>
-              </a:spcAft>
-              <a:buNone/>
-            </a:pPr>
-            <a:r>
-              <a:rPr lang="en"/>
-              <a:t>SUPERS</a:t>
-            </a:r>
-            <a:endParaRPr/>
-          </a:p>
-        </p:txBody>
-      </p:sp>
-      <p:sp>
-        <p:nvSpPr>
-          <p:cNvPr id="63" name="P1_LOWER_3RD"/>
-          <p:cNvSpPr/>
-          <p:nvPr/>
-        </p:nvSpPr>
-        <p:spPr>
-          <a:xfrm>
-            <a:off x="455900" y="3928050"/>
-            <a:ext cx="2697000" cy="288600"/>
-          </a:xfrm>
-          <a:prstGeom prst="rect">
-            <a:avLst/>
-          </a:prstGeom>
-          <a:solidFill>
-            <a:schemeClr val="lt2"/>
-          </a:solidFill>
-          <a:ln cap="flat" cmpd="sng" w="9525">
-            <a:solidFill>
-              <a:schemeClr val="dk2"/>
-            </a:solidFill>
-            <a:prstDash val="solid"/>
-            <a:round/>
-            <a:headEnd len="sm" w="sm" type="none"/>
-            <a:tailEnd len="sm" w="sm" type="none"/>
-          </a:ln>
-        </p:spPr>
-        <p:txBody>
-          <a:bodyPr anchorCtr="0" anchor="ctr" bIns="91425" lIns="91425" spcFirstLastPara="1" rIns="91425" wrap="square" tIns="91425">
-            <a:noAutofit/>
-          </a:bodyPr>
-          <a:lstStyle/>
-          <a:p>
-            <a:pPr indent="0" lvl="0" marL="0" rtl="0" algn="ctr">
-              <a:spcBef>
-                <a:spcPts val="0"/>
-              </a:spcBef>
-              <a:spcAft>
-                <a:spcPts val="0"/>
-              </a:spcAft>
-              <a:buNone/>
-            </a:pPr>
-            <a:r>
-              <a:rPr lang="en"/>
-              <a:t>LOWER 3RD</a:t>
-            </a:r>
-            <a:endParaRPr/>
-          </a:p>
-        </p:txBody>
-      </p:sp>
-      <p:sp>
-        <p:nvSpPr>
-          <p:cNvPr id="64" name="P1_VO_SFX"/>
-          <p:cNvSpPr/>
-          <p:nvPr/>
-        </p:nvSpPr>
-        <p:spPr>
-          <a:xfrm>
-            <a:off x="455900" y="4296525"/>
-            <a:ext cx="2697000" cy="288600"/>
-          </a:xfrm>
-          <a:prstGeom prst="rect">
-            <a:avLst/>
-          </a:prstGeom>
-          <a:solidFill>
-            <a:schemeClr val="lt2"/>
-          </a:solidFill>
-          <a:ln cap="flat" cmpd="sng" w="9525">
-            <a:solidFill>
-              <a:schemeClr val="dk2"/>
-            </a:solidFill>
-            <a:prstDash val="solid"/>
-            <a:round/>
-            <a:headEnd len="sm" w="sm" type="none"/>
-            <a:tailEnd len="sm" w="sm" type="none"/>
-          </a:ln>
-        </p:spPr>
-        <p:txBody>
-          <a:bodyPr anchorCtr="0" anchor="ctr" bIns="91425" lIns="91425" spcFirstLastPara="1" rIns="91425" wrap="square" tIns="91425">
-            <a:noAutofit/>
-          </a:bodyPr>
-          <a:lstStyle/>
-          <a:p>
-            <a:pPr indent="0" lvl="0" marL="0" rtl="0" algn="ctr">
-              <a:spcBef>
-                <a:spcPts val="0"/>
-              </a:spcBef>
-              <a:spcAft>
-                <a:spcPts val="0"/>
-              </a:spcAft>
-              <a:buNone/>
-            </a:pPr>
-            <a:r>
-              <a:rPr lang="en"/>
-              <a:t>VO / SFX</a:t>
-            </a:r>
-            <a:endParaRPr/>
-          </a:p>
-        </p:txBody>
-      </p:sp>
-      <p:sp>
-        <p:nvSpPr>
-          <p:cNvPr id="65" name="P4_SHOT_SIZE"/>
-          <p:cNvSpPr/>
-          <p:nvPr/>
-        </p:nvSpPr>
-        <p:spPr>
-          <a:xfrm>
-            <a:off x="3241688" y="2096925"/>
-            <a:ext cx="2697000" cy="288600"/>
-          </a:xfrm>
-          <a:prstGeom prst="rect">
-            <a:avLst/>
-          </a:prstGeom>
-          <a:solidFill>
-            <a:schemeClr val="lt2"/>
-          </a:solidFill>
-          <a:ln cap="flat" cmpd="sng" w="9525">
-            <a:solidFill>
-              <a:schemeClr val="dk2"/>
-            </a:solidFill>
-            <a:prstDash val="solid"/>
-            <a:round/>
-            <a:headEnd len="sm" w="sm" type="none"/>
-            <a:tailEnd len="sm" w="sm" type="none"/>
-          </a:ln>
-        </p:spPr>
-        <p:txBody>
-          <a:bodyPr anchorCtr="0" anchor="ctr" bIns="91425" lIns="91425" spcFirstLastPara="1" rIns="91425" wrap="square" tIns="91425">
-            <a:noAutofit/>
-          </a:bodyPr>
-          <a:lstStyle/>
-          <a:p>
-            <a:pPr indent="0" lvl="0" marL="0" rtl="0" algn="ctr">
-              <a:spcBef>
-                <a:spcPts val="0"/>
-              </a:spcBef>
-              <a:spcAft>
-                <a:spcPts val="0"/>
-              </a:spcAft>
-              <a:buNone/>
-            </a:pPr>
-            <a:r>
-              <a:rPr lang="en"/>
-              <a:t>SHOT SIZE</a:t>
-            </a:r>
-            <a:endParaRPr/>
-          </a:p>
-        </p:txBody>
-      </p:sp>
-      <p:sp>
-        <p:nvSpPr>
-          <p:cNvPr id="66" name="P3_SHOT_DESCRIPTION"/>
-          <p:cNvSpPr/>
-          <p:nvPr/>
-        </p:nvSpPr>
-        <p:spPr>
-          <a:xfrm>
-            <a:off x="3241663" y="2465400"/>
-            <a:ext cx="2697000" cy="1014300"/>
-          </a:xfrm>
-          <a:prstGeom prst="rect">
-            <a:avLst/>
-          </a:prstGeom>
-          <a:solidFill>
-            <a:schemeClr val="lt2"/>
-          </a:solidFill>
-          <a:ln cap="flat" cmpd="sng" w="9525">
-            <a:solidFill>
-              <a:schemeClr val="dk2"/>
-            </a:solidFill>
-            <a:prstDash val="solid"/>
-            <a:round/>
-            <a:headEnd len="sm" w="sm" type="none"/>
-            <a:tailEnd len="sm" w="sm" type="none"/>
-          </a:ln>
-        </p:spPr>
-        <p:txBody>
-          <a:bodyPr anchorCtr="0" anchor="ctr" bIns="91425" lIns="91425" spcFirstLastPara="1" rIns="91425" wrap="square" tIns="91425">
-            <a:noAutofit/>
-          </a:bodyPr>
-          <a:lstStyle/>
-          <a:p>
-            <a:pPr indent="0" lvl="0" marL="0" rtl="0" algn="ctr">
-              <a:spcBef>
-                <a:spcPts val="0"/>
-              </a:spcBef>
-              <a:spcAft>
-                <a:spcPts val="0"/>
-              </a:spcAft>
-              <a:buNone/>
-            </a:pPr>
-            <a:r>
-              <a:rPr lang="en"/>
-              <a:t>SHOT DESCRIPTION</a:t>
-            </a:r>
-            <a:endParaRPr/>
-          </a:p>
-        </p:txBody>
-      </p:sp>
-      <p:sp>
-        <p:nvSpPr>
-          <p:cNvPr id="67" name="P3_SUPERS"/>
-          <p:cNvSpPr/>
-          <p:nvPr/>
-        </p:nvSpPr>
-        <p:spPr>
-          <a:xfrm>
-            <a:off x="3241663" y="3559575"/>
-            <a:ext cx="2697000" cy="288600"/>
-          </a:xfrm>
-          <a:prstGeom prst="rect">
-            <a:avLst/>
-          </a:prstGeom>
-          <a:solidFill>
-            <a:schemeClr val="lt2"/>
-          </a:solidFill>
-          <a:ln cap="flat" cmpd="sng" w="9525">
-            <a:solidFill>
-              <a:schemeClr val="dk2"/>
-            </a:solidFill>
-            <a:prstDash val="solid"/>
-            <a:round/>
-            <a:headEnd len="sm" w="sm" type="none"/>
-            <a:tailEnd len="sm" w="sm" type="none"/>
-          </a:ln>
-        </p:spPr>
-        <p:txBody>
-          <a:bodyPr anchorCtr="0" anchor="ctr" bIns="91425" lIns="91425" spcFirstLastPara="1" rIns="91425" wrap="square" tIns="91425">
-            <a:noAutofit/>
-          </a:bodyPr>
-          <a:lstStyle/>
-          <a:p>
-            <a:pPr indent="0" lvl="0" marL="0" rtl="0" algn="ctr">
-              <a:spcBef>
-                <a:spcPts val="0"/>
-              </a:spcBef>
-              <a:spcAft>
-                <a:spcPts val="0"/>
-              </a:spcAft>
-              <a:buNone/>
-            </a:pPr>
-            <a:r>
-              <a:rPr lang="en"/>
-              <a:t>SUPERS</a:t>
-            </a:r>
-            <a:endParaRPr/>
-          </a:p>
-        </p:txBody>
-      </p:sp>
-      <p:sp>
-        <p:nvSpPr>
-          <p:cNvPr id="68" name="P3_LOWER_3RD"/>
-          <p:cNvSpPr/>
-          <p:nvPr/>
-        </p:nvSpPr>
-        <p:spPr>
-          <a:xfrm>
-            <a:off x="3241663" y="3928050"/>
-            <a:ext cx="2697000" cy="288600"/>
-          </a:xfrm>
-          <a:prstGeom prst="rect">
-            <a:avLst/>
-          </a:prstGeom>
-          <a:solidFill>
-            <a:schemeClr val="lt2"/>
-          </a:solidFill>
-          <a:ln cap="flat" cmpd="sng" w="9525">
-            <a:solidFill>
-              <a:schemeClr val="dk2"/>
-            </a:solidFill>
-            <a:prstDash val="solid"/>
-            <a:round/>
-            <a:headEnd len="sm" w="sm" type="none"/>
-            <a:tailEnd len="sm" w="sm" type="none"/>
-          </a:ln>
-        </p:spPr>
-        <p:txBody>
-          <a:bodyPr anchorCtr="0" anchor="ctr" bIns="91425" lIns="91425" spcFirstLastPara="1" rIns="91425" wrap="square" tIns="91425">
-            <a:noAutofit/>
-          </a:bodyPr>
-          <a:lstStyle/>
-          <a:p>
-            <a:pPr indent="0" lvl="0" marL="0" rtl="0" algn="ctr">
-              <a:spcBef>
-                <a:spcPts val="0"/>
-              </a:spcBef>
-              <a:spcAft>
-                <a:spcPts val="0"/>
-              </a:spcAft>
-              <a:buNone/>
-            </a:pPr>
-            <a:r>
-              <a:rPr lang="en"/>
-              <a:t>LOWER 3RD</a:t>
-            </a:r>
-            <a:endParaRPr/>
-          </a:p>
-        </p:txBody>
-      </p:sp>
-      <p:sp>
-        <p:nvSpPr>
-          <p:cNvPr id="69" name="P3_VO_SFX"/>
-          <p:cNvSpPr/>
-          <p:nvPr/>
-        </p:nvSpPr>
-        <p:spPr>
-          <a:xfrm>
-            <a:off x="3241663" y="4296525"/>
-            <a:ext cx="2697000" cy="288600"/>
-          </a:xfrm>
-          <a:prstGeom prst="rect">
-            <a:avLst/>
-          </a:prstGeom>
-          <a:solidFill>
-            <a:schemeClr val="lt2"/>
-          </a:solidFill>
-          <a:ln cap="flat" cmpd="sng" w="9525">
-            <a:solidFill>
-              <a:schemeClr val="dk2"/>
-            </a:solidFill>
-            <a:prstDash val="solid"/>
-            <a:round/>
-            <a:headEnd len="sm" w="sm" type="none"/>
-            <a:tailEnd len="sm" w="sm" type="none"/>
-          </a:ln>
-        </p:spPr>
-        <p:txBody>
-          <a:bodyPr anchorCtr="0" anchor="ctr" bIns="91425" lIns="91425" spcFirstLastPara="1" rIns="91425" wrap="square" tIns="91425">
-            <a:noAutofit/>
-          </a:bodyPr>
-          <a:lstStyle/>
-          <a:p>
-            <a:pPr indent="0" lvl="0" marL="0" rtl="0" algn="ctr">
-              <a:spcBef>
-                <a:spcPts val="0"/>
-              </a:spcBef>
-              <a:spcAft>
-                <a:spcPts val="0"/>
-              </a:spcAft>
-              <a:buNone/>
-            </a:pPr>
-            <a:r>
-              <a:rPr lang="en"/>
-              <a:t>VO / SFX</a:t>
-            </a:r>
-            <a:endParaRPr/>
-          </a:p>
-        </p:txBody>
-      </p:sp>
-      <p:sp>
-        <p:nvSpPr>
-          <p:cNvPr id="70" name="P6_SHOT_SIZE"/>
-          <p:cNvSpPr/>
-          <p:nvPr/>
-        </p:nvSpPr>
-        <p:spPr>
-          <a:xfrm>
-            <a:off x="6027488" y="2096925"/>
-            <a:ext cx="2697000" cy="288600"/>
-          </a:xfrm>
-          <a:prstGeom prst="rect">
-            <a:avLst/>
-          </a:prstGeom>
-          <a:solidFill>
-            <a:schemeClr val="lt2"/>
-          </a:solidFill>
-          <a:ln cap="flat" cmpd="sng" w="9525">
-            <a:solidFill>
-              <a:schemeClr val="dk2"/>
-            </a:solidFill>
-            <a:prstDash val="solid"/>
-            <a:round/>
-            <a:headEnd len="sm" w="sm" type="none"/>
-            <a:tailEnd len="sm" w="sm" type="none"/>
-          </a:ln>
-        </p:spPr>
-        <p:txBody>
-          <a:bodyPr anchorCtr="0" anchor="ctr" bIns="91425" lIns="91425" spcFirstLastPara="1" rIns="91425" wrap="square" tIns="91425">
-            <a:noAutofit/>
-          </a:bodyPr>
-          <a:lstStyle/>
-          <a:p>
-            <a:pPr indent="0" lvl="0" marL="0" rtl="0" algn="ctr">
-              <a:spcBef>
-                <a:spcPts val="0"/>
-              </a:spcBef>
-              <a:spcAft>
-                <a:spcPts val="0"/>
-              </a:spcAft>
-              <a:buNone/>
-            </a:pPr>
-            <a:r>
-              <a:rPr lang="en"/>
-              <a:t>SHOT SIZE</a:t>
-            </a:r>
-            <a:endParaRPr/>
-          </a:p>
-        </p:txBody>
-      </p:sp>
-      <p:sp>
-        <p:nvSpPr>
-          <p:cNvPr id="71" name="P5_SHOT_DESCRIPTION"/>
-          <p:cNvSpPr/>
-          <p:nvPr/>
-        </p:nvSpPr>
-        <p:spPr>
-          <a:xfrm>
-            <a:off x="6027463" y="2465400"/>
-            <a:ext cx="2697000" cy="1014300"/>
-          </a:xfrm>
-          <a:prstGeom prst="rect">
-            <a:avLst/>
-          </a:prstGeom>
-          <a:solidFill>
-            <a:schemeClr val="lt2"/>
-          </a:solidFill>
-          <a:ln cap="flat" cmpd="sng" w="9525">
-            <a:solidFill>
-              <a:schemeClr val="dk2"/>
-            </a:solidFill>
-            <a:prstDash val="solid"/>
-            <a:round/>
-            <a:headEnd len="sm" w="sm" type="none"/>
-            <a:tailEnd len="sm" w="sm" type="none"/>
-          </a:ln>
-        </p:spPr>
-        <p:txBody>
-          <a:bodyPr anchorCtr="0" anchor="ctr" bIns="91425" lIns="91425" spcFirstLastPara="1" rIns="91425" wrap="square" tIns="91425">
-            <a:noAutofit/>
-          </a:bodyPr>
-          <a:lstStyle/>
-          <a:p>
-            <a:pPr indent="0" lvl="0" marL="0" rtl="0" algn="ctr">
-              <a:spcBef>
-                <a:spcPts val="0"/>
-              </a:spcBef>
-              <a:spcAft>
-                <a:spcPts val="0"/>
-              </a:spcAft>
-              <a:buNone/>
-            </a:pPr>
-            <a:r>
-              <a:rPr lang="en"/>
-              <a:t>SHOT DESCRIPTION</a:t>
-            </a:r>
-            <a:endParaRPr/>
-          </a:p>
-        </p:txBody>
-      </p:sp>
-      <p:sp>
-        <p:nvSpPr>
-          <p:cNvPr id="72" name="P5_SUPERS"/>
-          <p:cNvSpPr/>
-          <p:nvPr/>
-        </p:nvSpPr>
-        <p:spPr>
-          <a:xfrm>
-            <a:off x="6027463" y="3559575"/>
-            <a:ext cx="2697000" cy="288600"/>
-          </a:xfrm>
-          <a:prstGeom prst="rect">
-            <a:avLst/>
-          </a:prstGeom>
-          <a:solidFill>
-            <a:schemeClr val="lt2"/>
-          </a:solidFill>
-          <a:ln cap="flat" cmpd="sng" w="9525">
-            <a:solidFill>
-              <a:schemeClr val="dk2"/>
-            </a:solidFill>
-            <a:prstDash val="solid"/>
-            <a:round/>
-            <a:headEnd len="sm" w="sm" type="none"/>
-            <a:tailEnd len="sm" w="sm" type="none"/>
-          </a:ln>
-        </p:spPr>
-        <p:txBody>
-          <a:bodyPr anchorCtr="0" anchor="ctr" bIns="91425" lIns="91425" spcFirstLastPara="1" rIns="91425" wrap="square" tIns="91425">
-            <a:noAutofit/>
-          </a:bodyPr>
-          <a:lstStyle/>
-          <a:p>
-            <a:pPr indent="0" lvl="0" marL="0" rtl="0" algn="ctr">
-              <a:spcBef>
-                <a:spcPts val="0"/>
-              </a:spcBef>
-              <a:spcAft>
-                <a:spcPts val="0"/>
-              </a:spcAft>
-              <a:buNone/>
-            </a:pPr>
-            <a:r>
-              <a:rPr lang="en"/>
-              <a:t>SUPERS</a:t>
-            </a:r>
-            <a:endParaRPr/>
-          </a:p>
-        </p:txBody>
-      </p:sp>
-      <p:sp>
-        <p:nvSpPr>
-          <p:cNvPr id="73" name="P5_LOWER_3RD"/>
-          <p:cNvSpPr/>
-          <p:nvPr/>
-        </p:nvSpPr>
-        <p:spPr>
-          <a:xfrm>
-            <a:off x="6027463" y="3928050"/>
-            <a:ext cx="2697000" cy="288600"/>
-          </a:xfrm>
-          <a:prstGeom prst="rect">
-            <a:avLst/>
-          </a:prstGeom>
-          <a:solidFill>
-            <a:schemeClr val="lt2"/>
-          </a:solidFill>
-          <a:ln cap="flat" cmpd="sng" w="9525">
-            <a:solidFill>
-              <a:schemeClr val="dk2"/>
-            </a:solidFill>
-            <a:prstDash val="solid"/>
-            <a:round/>
-            <a:headEnd len="sm" w="sm" type="none"/>
-            <a:tailEnd len="sm" w="sm" type="none"/>
-          </a:ln>
-        </p:spPr>
-        <p:txBody>
-          <a:bodyPr anchorCtr="0" anchor="ctr" bIns="91425" lIns="91425" spcFirstLastPara="1" rIns="91425" wrap="square" tIns="91425">
-            <a:noAutofit/>
-          </a:bodyPr>
-          <a:lstStyle/>
-          <a:p>
-            <a:pPr indent="0" lvl="0" marL="0" rtl="0" algn="ctr">
-              <a:spcBef>
-                <a:spcPts val="0"/>
-              </a:spcBef>
-              <a:spcAft>
-                <a:spcPts val="0"/>
-              </a:spcAft>
-              <a:buNone/>
-            </a:pPr>
-            <a:r>
-              <a:rPr lang="en"/>
-              <a:t>LOWER 3RD</a:t>
-            </a:r>
-            <a:endParaRPr/>
-          </a:p>
-        </p:txBody>
-      </p:sp>
-      <p:sp>
-        <p:nvSpPr>
-          <p:cNvPr id="74" name="P5_VO_SFX"/>
-          <p:cNvSpPr/>
-          <p:nvPr/>
-        </p:nvSpPr>
-        <p:spPr>
-          <a:xfrm>
-            <a:off x="6027463" y="4296525"/>
-            <a:ext cx="2697000" cy="288600"/>
-          </a:xfrm>
-          <a:prstGeom prst="rect">
-            <a:avLst/>
-          </a:prstGeom>
-          <a:solidFill>
-            <a:schemeClr val="lt2"/>
-          </a:solidFill>
-          <a:ln cap="flat" cmpd="sng" w="9525">
-            <a:solidFill>
-              <a:schemeClr val="dk2"/>
-            </a:solidFill>
-            <a:prstDash val="solid"/>
-            <a:round/>
-            <a:headEnd len="sm" w="sm" type="none"/>
-            <a:tailEnd len="sm" w="sm" type="none"/>
-          </a:ln>
-        </p:spPr>
-        <p:txBody>
-          <a:bodyPr anchorCtr="0" anchor="ctr" bIns="91425" lIns="91425" spcFirstLastPara="1" rIns="91425" wrap="square" tIns="91425">
-            <a:noAutofit/>
-          </a:bodyPr>
-          <a:lstStyle/>
-          <a:p>
-            <a:pPr indent="0" lvl="0" marL="0" rtl="0" algn="ctr">
-              <a:spcBef>
-                <a:spcPts val="0"/>
-              </a:spcBef>
-              <a:spcAft>
-                <a:spcPts val="0"/>
-              </a:spcAft>
-              <a:buNone/>
-            </a:pPr>
-            <a:r>
-              <a:rPr lang="en"/>
-              <a:t>VO / SFX</a:t>
-            </a:r>
-            <a:endParaRPr/>
-          </a:p>
-        </p:txBody>
-      </p:sp>
-      <p:sp>
-        <p:nvSpPr>
           <p:cNvPr id="75" name="PANEL_FRAME_1"/>
           <p:cNvSpPr/>
           <p:nvPr/>
@@ -6486,6 +5604,888 @@
               </a:rPr>
               <a:t>Panel</a:t>
             </a:r>
+          </a:p>
+        </p:txBody>
+      </p:sp>
+      <p:sp>
+        <p:nvSpPr>
+          <p:cNvPr id="57" name="P1_NUMBER"/>
+          <p:cNvSpPr/>
+          <p:nvPr/>
+        </p:nvSpPr>
+        <p:spPr>
+          <a:xfrm>
+            <a:off x="2780650" y="1549975"/>
+            <a:ext cx="372300" cy="379800"/>
+          </a:xfrm>
+          <a:prstGeom prst="rect">
+            <a:avLst/>
+          </a:prstGeom>
+          <a:solidFill>
+            <a:srgbClr val="00FFFF"/>
+          </a:solidFill>
+          <a:ln>
+            <a:noFill/>
+          </a:ln>
+        </p:spPr>
+        <p:txBody>
+          <a:bodyPr anchorCtr="0" anchor="ctr" bIns="91425" lIns="91425" spcFirstLastPara="1" rIns="91425" wrap="square" tIns="91425">
+            <a:noAutofit/>
+          </a:bodyPr>
+          <a:lstStyle/>
+          <a:p>
+            <a:pPr indent="0" lvl="0" marL="0" rtl="0" algn="ctr">
+              <a:spcBef>
+                <a:spcPts val="0"/>
+              </a:spcBef>
+              <a:spcAft>
+                <a:spcPts val="0"/>
+              </a:spcAft>
+              <a:buNone/>
+            </a:pPr>
+            <a:r>
+              <a:rPr b="1" lang="en" sz="1200"/>
+              <a:t>1</a:t>
+            </a:r>
+            <a:endParaRPr b="1" sz="1200"/>
+          </a:p>
+        </p:txBody>
+      </p:sp>
+      <p:sp>
+        <p:nvSpPr>
+          <p:cNvPr id="58" name="P2_NUMBER"/>
+          <p:cNvSpPr/>
+          <p:nvPr/>
+        </p:nvSpPr>
+        <p:spPr>
+          <a:xfrm>
+            <a:off x="5548250" y="1549975"/>
+            <a:ext cx="372300" cy="379800"/>
+          </a:xfrm>
+          <a:prstGeom prst="rect">
+            <a:avLst/>
+          </a:prstGeom>
+          <a:solidFill>
+            <a:srgbClr val="00FFFF"/>
+          </a:solidFill>
+          <a:ln>
+            <a:noFill/>
+          </a:ln>
+        </p:spPr>
+        <p:txBody>
+          <a:bodyPr anchorCtr="0" anchor="ctr" bIns="91425" lIns="91425" spcFirstLastPara="1" rIns="91425" wrap="square" tIns="91425">
+            <a:noAutofit/>
+          </a:bodyPr>
+          <a:lstStyle/>
+          <a:p>
+            <a:pPr indent="0" lvl="0" marL="0" rtl="0" algn="ctr">
+              <a:spcBef>
+                <a:spcPts val="0"/>
+              </a:spcBef>
+              <a:spcAft>
+                <a:spcPts val="0"/>
+              </a:spcAft>
+              <a:buNone/>
+            </a:pPr>
+            <a:r>
+              <a:rPr b="1" lang="en" sz="1200"/>
+              <a:t>2</a:t>
+            </a:r>
+            <a:endParaRPr b="1" sz="1200"/>
+          </a:p>
+        </p:txBody>
+      </p:sp>
+      <p:sp>
+        <p:nvSpPr>
+          <p:cNvPr id="59" name="P3_NUMBER"/>
+          <p:cNvSpPr/>
+          <p:nvPr/>
+        </p:nvSpPr>
+        <p:spPr>
+          <a:xfrm>
+            <a:off x="8315850" y="1549975"/>
+            <a:ext cx="372300" cy="379800"/>
+          </a:xfrm>
+          <a:prstGeom prst="rect">
+            <a:avLst/>
+          </a:prstGeom>
+          <a:solidFill>
+            <a:srgbClr val="00FFFF"/>
+          </a:solidFill>
+          <a:ln>
+            <a:noFill/>
+          </a:ln>
+        </p:spPr>
+        <p:txBody>
+          <a:bodyPr anchorCtr="0" anchor="ctr" bIns="91425" lIns="91425" spcFirstLastPara="1" rIns="91425" wrap="square" tIns="91425">
+            <a:noAutofit/>
+          </a:bodyPr>
+          <a:lstStyle/>
+          <a:p>
+            <a:pPr indent="0" lvl="0" marL="0" rtl="0" algn="ctr">
+              <a:spcBef>
+                <a:spcPts val="0"/>
+              </a:spcBef>
+              <a:spcAft>
+                <a:spcPts val="0"/>
+              </a:spcAft>
+              <a:buNone/>
+            </a:pPr>
+            <a:r>
+              <a:rPr b="1" lang="en" sz="1200"/>
+              <a:t>3</a:t>
+            </a:r>
+            <a:endParaRPr b="1" sz="1200"/>
+          </a:p>
+        </p:txBody>
+      </p:sp>
+      <p:sp>
+        <p:nvSpPr>
+          <p:cNvPr id="60" name="P1_SHOT_SIZE"/>
+          <p:cNvSpPr/>
+          <p:nvPr/>
+        </p:nvSpPr>
+        <p:spPr>
+          <a:xfrm>
+            <a:off x="455925" y="2096925"/>
+            <a:ext cx="2697000" cy="288600"/>
+          </a:xfrm>
+          <a:prstGeom prst="rect">
+            <a:avLst/>
+          </a:prstGeom>
+          <a:solidFill>
+            <a:schemeClr val="lt2"/>
+          </a:solidFill>
+          <a:ln cap="flat" cmpd="sng" w="9525">
+            <a:solidFill>
+              <a:schemeClr val="dk2"/>
+            </a:solidFill>
+            <a:prstDash val="solid"/>
+            <a:round/>
+            <a:headEnd len="sm" w="sm" type="none"/>
+            <a:tailEnd len="sm" w="sm" type="none"/>
+          </a:ln>
+        </p:spPr>
+        <p:txBody>
+          <a:bodyPr anchorCtr="0" anchor="ctr" bIns="91425" lIns="91425" spcFirstLastPara="1" rIns="91425" wrap="square" tIns="91425">
+            <a:noAutofit/>
+          </a:bodyPr>
+          <a:lstStyle/>
+          <a:p>
+            <a:pPr indent="0" lvl="0" marL="0" rtl="0" algn="ctr">
+              <a:spcBef>
+                <a:spcPts val="0"/>
+              </a:spcBef>
+              <a:spcAft>
+                <a:spcPts val="0"/>
+              </a:spcAft>
+              <a:buNone/>
+            </a:pPr>
+            <a:r>
+              <a:rPr lang="en"/>
+              <a:t>SHOT SIZE</a:t>
+            </a:r>
+            <a:endParaRPr/>
+          </a:p>
+        </p:txBody>
+      </p:sp>
+      <p:sp>
+        <p:nvSpPr>
+          <p:cNvPr id="61" name="P1_SHOT_DESCRIPTION"/>
+          <p:cNvSpPr/>
+          <p:nvPr/>
+        </p:nvSpPr>
+        <p:spPr>
+          <a:xfrm>
+            <a:off x="455900" y="2465400"/>
+            <a:ext cx="2697000" cy="1014300"/>
+          </a:xfrm>
+          <a:prstGeom prst="rect">
+            <a:avLst/>
+          </a:prstGeom>
+          <a:solidFill>
+            <a:schemeClr val="lt2"/>
+          </a:solidFill>
+          <a:ln cap="flat" cmpd="sng" w="9525">
+            <a:solidFill>
+              <a:schemeClr val="dk2"/>
+            </a:solidFill>
+            <a:prstDash val="solid"/>
+            <a:round/>
+            <a:headEnd len="sm" w="sm" type="none"/>
+            <a:tailEnd len="sm" w="sm" type="none"/>
+          </a:ln>
+        </p:spPr>
+        <p:txBody>
+          <a:bodyPr anchorCtr="0" anchor="ctr" bIns="91425" lIns="91425" spcFirstLastPara="1" rIns="91425" wrap="square" tIns="91425">
+            <a:noAutofit/>
+          </a:bodyPr>
+          <a:lstStyle/>
+          <a:p>
+            <a:pPr indent="0" lvl="0" marL="0" rtl="0" algn="ctr">
+              <a:spcBef>
+                <a:spcPts val="0"/>
+              </a:spcBef>
+              <a:spcAft>
+                <a:spcPts val="0"/>
+              </a:spcAft>
+              <a:buNone/>
+            </a:pPr>
+            <a:r>
+              <a:rPr lang="en"/>
+              <a:t>SHOT DESCRIPTION</a:t>
+            </a:r>
+            <a:endParaRPr/>
+          </a:p>
+        </p:txBody>
+      </p:sp>
+      <p:sp>
+        <p:nvSpPr>
+          <p:cNvPr id="62" name="P1_SUPERS"/>
+          <p:cNvSpPr/>
+          <p:nvPr/>
+        </p:nvSpPr>
+        <p:spPr>
+          <a:xfrm>
+            <a:off x="455900" y="3559575"/>
+            <a:ext cx="2697000" cy="288600"/>
+          </a:xfrm>
+          <a:prstGeom prst="rect">
+            <a:avLst/>
+          </a:prstGeom>
+          <a:solidFill>
+            <a:schemeClr val="lt2"/>
+          </a:solidFill>
+          <a:ln cap="flat" cmpd="sng" w="9525">
+            <a:solidFill>
+              <a:schemeClr val="dk2"/>
+            </a:solidFill>
+            <a:prstDash val="solid"/>
+            <a:round/>
+            <a:headEnd len="sm" w="sm" type="none"/>
+            <a:tailEnd len="sm" w="sm" type="none"/>
+          </a:ln>
+        </p:spPr>
+        <p:txBody>
+          <a:bodyPr anchorCtr="0" anchor="ctr" bIns="91425" lIns="91425" spcFirstLastPara="1" rIns="91425" wrap="square" tIns="91425">
+            <a:noAutofit/>
+          </a:bodyPr>
+          <a:lstStyle/>
+          <a:p>
+            <a:pPr indent="0" lvl="0" marL="0" rtl="0" algn="ctr">
+              <a:spcBef>
+                <a:spcPts val="0"/>
+              </a:spcBef>
+              <a:spcAft>
+                <a:spcPts val="0"/>
+              </a:spcAft>
+              <a:buNone/>
+            </a:pPr>
+            <a:r>
+              <a:rPr lang="en"/>
+              <a:t>SUPERS</a:t>
+            </a:r>
+            <a:endParaRPr/>
+          </a:p>
+        </p:txBody>
+      </p:sp>
+      <p:sp>
+        <p:nvSpPr>
+          <p:cNvPr id="63" name="P1_LOWER_3RD"/>
+          <p:cNvSpPr/>
+          <p:nvPr/>
+        </p:nvSpPr>
+        <p:spPr>
+          <a:xfrm>
+            <a:off x="455900" y="3928050"/>
+            <a:ext cx="2697000" cy="288600"/>
+          </a:xfrm>
+          <a:prstGeom prst="rect">
+            <a:avLst/>
+          </a:prstGeom>
+          <a:solidFill>
+            <a:schemeClr val="lt2"/>
+          </a:solidFill>
+          <a:ln cap="flat" cmpd="sng" w="9525">
+            <a:solidFill>
+              <a:schemeClr val="dk2"/>
+            </a:solidFill>
+            <a:prstDash val="solid"/>
+            <a:round/>
+            <a:headEnd len="sm" w="sm" type="none"/>
+            <a:tailEnd len="sm" w="sm" type="none"/>
+          </a:ln>
+        </p:spPr>
+        <p:txBody>
+          <a:bodyPr anchorCtr="0" anchor="ctr" bIns="91425" lIns="91425" spcFirstLastPara="1" rIns="91425" wrap="square" tIns="91425">
+            <a:noAutofit/>
+          </a:bodyPr>
+          <a:lstStyle/>
+          <a:p>
+            <a:pPr indent="0" lvl="0" marL="0" rtl="0" algn="ctr">
+              <a:spcBef>
+                <a:spcPts val="0"/>
+              </a:spcBef>
+              <a:spcAft>
+                <a:spcPts val="0"/>
+              </a:spcAft>
+              <a:buNone/>
+            </a:pPr>
+            <a:r>
+              <a:rPr lang="en"/>
+              <a:t>LOWER 3RD</a:t>
+            </a:r>
+            <a:endParaRPr/>
+          </a:p>
+        </p:txBody>
+      </p:sp>
+      <p:sp>
+        <p:nvSpPr>
+          <p:cNvPr id="64" name="P1_VO_SFX"/>
+          <p:cNvSpPr/>
+          <p:nvPr/>
+        </p:nvSpPr>
+        <p:spPr>
+          <a:xfrm>
+            <a:off x="455900" y="4296525"/>
+            <a:ext cx="2697000" cy="288600"/>
+          </a:xfrm>
+          <a:prstGeom prst="rect">
+            <a:avLst/>
+          </a:prstGeom>
+          <a:solidFill>
+            <a:schemeClr val="lt2"/>
+          </a:solidFill>
+          <a:ln cap="flat" cmpd="sng" w="9525">
+            <a:solidFill>
+              <a:schemeClr val="dk2"/>
+            </a:solidFill>
+            <a:prstDash val="solid"/>
+            <a:round/>
+            <a:headEnd len="sm" w="sm" type="none"/>
+            <a:tailEnd len="sm" w="sm" type="none"/>
+          </a:ln>
+        </p:spPr>
+        <p:txBody>
+          <a:bodyPr anchorCtr="0" anchor="ctr" bIns="91425" lIns="91425" spcFirstLastPara="1" rIns="91425" wrap="square" tIns="91425">
+            <a:noAutofit/>
+          </a:bodyPr>
+          <a:lstStyle/>
+          <a:p>
+            <a:pPr indent="0" lvl="0" marL="0" rtl="0" algn="ctr">
+              <a:spcBef>
+                <a:spcPts val="0"/>
+              </a:spcBef>
+              <a:spcAft>
+                <a:spcPts val="0"/>
+              </a:spcAft>
+              <a:buNone/>
+            </a:pPr>
+            <a:r>
+              <a:rPr lang="en"/>
+              <a:t>VO / SFX</a:t>
+            </a:r>
+            <a:endParaRPr/>
+          </a:p>
+        </p:txBody>
+      </p:sp>
+      <p:sp>
+        <p:nvSpPr>
+          <p:cNvPr id="65" name="P2_SHOT_SIZE"/>
+          <p:cNvSpPr/>
+          <p:nvPr/>
+        </p:nvSpPr>
+        <p:spPr>
+          <a:xfrm>
+            <a:off x="3241688" y="2096925"/>
+            <a:ext cx="2697000" cy="288600"/>
+          </a:xfrm>
+          <a:prstGeom prst="rect">
+            <a:avLst/>
+          </a:prstGeom>
+          <a:solidFill>
+            <a:schemeClr val="lt2"/>
+          </a:solidFill>
+          <a:ln cap="flat" cmpd="sng" w="9525">
+            <a:solidFill>
+              <a:schemeClr val="dk2"/>
+            </a:solidFill>
+            <a:prstDash val="solid"/>
+            <a:round/>
+            <a:headEnd len="sm" w="sm" type="none"/>
+            <a:tailEnd len="sm" w="sm" type="none"/>
+          </a:ln>
+        </p:spPr>
+        <p:txBody>
+          <a:bodyPr anchorCtr="0" anchor="ctr" bIns="91425" lIns="91425" spcFirstLastPara="1" rIns="91425" wrap="square" tIns="91425">
+            <a:noAutofit/>
+          </a:bodyPr>
+          <a:lstStyle/>
+          <a:p>
+            <a:pPr indent="0" lvl="0" marL="0" rtl="0" algn="ctr">
+              <a:spcBef>
+                <a:spcPts val="0"/>
+              </a:spcBef>
+              <a:spcAft>
+                <a:spcPts val="0"/>
+              </a:spcAft>
+              <a:buNone/>
+            </a:pPr>
+            <a:r>
+              <a:rPr lang="en"/>
+              <a:t>SHOT SIZE</a:t>
+            </a:r>
+            <a:endParaRPr/>
+          </a:p>
+        </p:txBody>
+      </p:sp>
+      <p:sp>
+        <p:nvSpPr>
+          <p:cNvPr id="66" name="P2_SHOT_DESCRIPTION"/>
+          <p:cNvSpPr/>
+          <p:nvPr/>
+        </p:nvSpPr>
+        <p:spPr>
+          <a:xfrm>
+            <a:off x="3241663" y="2465400"/>
+            <a:ext cx="2697000" cy="1014300"/>
+          </a:xfrm>
+          <a:prstGeom prst="rect">
+            <a:avLst/>
+          </a:prstGeom>
+          <a:solidFill>
+            <a:schemeClr val="lt2"/>
+          </a:solidFill>
+          <a:ln cap="flat" cmpd="sng" w="9525">
+            <a:solidFill>
+              <a:schemeClr val="dk2"/>
+            </a:solidFill>
+            <a:prstDash val="solid"/>
+            <a:round/>
+            <a:headEnd len="sm" w="sm" type="none"/>
+            <a:tailEnd len="sm" w="sm" type="none"/>
+          </a:ln>
+        </p:spPr>
+        <p:txBody>
+          <a:bodyPr anchorCtr="0" anchor="ctr" bIns="91425" lIns="91425" spcFirstLastPara="1" rIns="91425" wrap="square" tIns="91425">
+            <a:noAutofit/>
+          </a:bodyPr>
+          <a:lstStyle/>
+          <a:p>
+            <a:pPr indent="0" lvl="0" marL="0" rtl="0" algn="ctr">
+              <a:spcBef>
+                <a:spcPts val="0"/>
+              </a:spcBef>
+              <a:spcAft>
+                <a:spcPts val="0"/>
+              </a:spcAft>
+              <a:buNone/>
+            </a:pPr>
+            <a:r>
+              <a:rPr lang="en"/>
+              <a:t>SHOT DESCRIPTION</a:t>
+            </a:r>
+            <a:endParaRPr/>
+          </a:p>
+        </p:txBody>
+      </p:sp>
+      <p:sp>
+        <p:nvSpPr>
+          <p:cNvPr id="67" name="P2_SUPERS"/>
+          <p:cNvSpPr/>
+          <p:nvPr/>
+        </p:nvSpPr>
+        <p:spPr>
+          <a:xfrm>
+            <a:off x="3241663" y="3559575"/>
+            <a:ext cx="2697000" cy="288600"/>
+          </a:xfrm>
+          <a:prstGeom prst="rect">
+            <a:avLst/>
+          </a:prstGeom>
+          <a:solidFill>
+            <a:schemeClr val="lt2"/>
+          </a:solidFill>
+          <a:ln cap="flat" cmpd="sng" w="9525">
+            <a:solidFill>
+              <a:schemeClr val="dk2"/>
+            </a:solidFill>
+            <a:prstDash val="solid"/>
+            <a:round/>
+            <a:headEnd len="sm" w="sm" type="none"/>
+            <a:tailEnd len="sm" w="sm" type="none"/>
+          </a:ln>
+        </p:spPr>
+        <p:txBody>
+          <a:bodyPr anchorCtr="0" anchor="ctr" bIns="91425" lIns="91425" spcFirstLastPara="1" rIns="91425" wrap="square" tIns="91425">
+            <a:noAutofit/>
+          </a:bodyPr>
+          <a:lstStyle/>
+          <a:p>
+            <a:pPr indent="0" lvl="0" marL="0" rtl="0" algn="ctr">
+              <a:spcBef>
+                <a:spcPts val="0"/>
+              </a:spcBef>
+              <a:spcAft>
+                <a:spcPts val="0"/>
+              </a:spcAft>
+              <a:buNone/>
+            </a:pPr>
+            <a:r>
+              <a:rPr lang="en"/>
+              <a:t>SUPERS</a:t>
+            </a:r>
+            <a:endParaRPr/>
+          </a:p>
+        </p:txBody>
+      </p:sp>
+      <p:sp>
+        <p:nvSpPr>
+          <p:cNvPr id="68" name="P2_LOWER_3RD"/>
+          <p:cNvSpPr/>
+          <p:nvPr/>
+        </p:nvSpPr>
+        <p:spPr>
+          <a:xfrm>
+            <a:off x="3241663" y="3928050"/>
+            <a:ext cx="2697000" cy="288600"/>
+          </a:xfrm>
+          <a:prstGeom prst="rect">
+            <a:avLst/>
+          </a:prstGeom>
+          <a:solidFill>
+            <a:schemeClr val="lt2"/>
+          </a:solidFill>
+          <a:ln cap="flat" cmpd="sng" w="9525">
+            <a:solidFill>
+              <a:schemeClr val="dk2"/>
+            </a:solidFill>
+            <a:prstDash val="solid"/>
+            <a:round/>
+            <a:headEnd len="sm" w="sm" type="none"/>
+            <a:tailEnd len="sm" w="sm" type="none"/>
+          </a:ln>
+        </p:spPr>
+        <p:txBody>
+          <a:bodyPr anchorCtr="0" anchor="ctr" bIns="91425" lIns="91425" spcFirstLastPara="1" rIns="91425" wrap="square" tIns="91425">
+            <a:noAutofit/>
+          </a:bodyPr>
+          <a:lstStyle/>
+          <a:p>
+            <a:pPr indent="0" lvl="0" marL="0" rtl="0" algn="ctr">
+              <a:spcBef>
+                <a:spcPts val="0"/>
+              </a:spcBef>
+              <a:spcAft>
+                <a:spcPts val="0"/>
+              </a:spcAft>
+              <a:buNone/>
+            </a:pPr>
+            <a:r>
+              <a:rPr lang="en"/>
+              <a:t>LOWER 3RD</a:t>
+            </a:r>
+            <a:endParaRPr/>
+          </a:p>
+        </p:txBody>
+      </p:sp>
+      <p:sp>
+        <p:nvSpPr>
+          <p:cNvPr id="69" name="P2_VO_SFX"/>
+          <p:cNvSpPr/>
+          <p:nvPr/>
+        </p:nvSpPr>
+        <p:spPr>
+          <a:xfrm>
+            <a:off x="3241663" y="4296525"/>
+            <a:ext cx="2697000" cy="288600"/>
+          </a:xfrm>
+          <a:prstGeom prst="rect">
+            <a:avLst/>
+          </a:prstGeom>
+          <a:solidFill>
+            <a:schemeClr val="lt2"/>
+          </a:solidFill>
+          <a:ln cap="flat" cmpd="sng" w="9525">
+            <a:solidFill>
+              <a:schemeClr val="dk2"/>
+            </a:solidFill>
+            <a:prstDash val="solid"/>
+            <a:round/>
+            <a:headEnd len="sm" w="sm" type="none"/>
+            <a:tailEnd len="sm" w="sm" type="none"/>
+          </a:ln>
+        </p:spPr>
+        <p:txBody>
+          <a:bodyPr anchorCtr="0" anchor="ctr" bIns="91425" lIns="91425" spcFirstLastPara="1" rIns="91425" wrap="square" tIns="91425">
+            <a:noAutofit/>
+          </a:bodyPr>
+          <a:lstStyle/>
+          <a:p>
+            <a:pPr indent="0" lvl="0" marL="0" rtl="0" algn="ctr">
+              <a:spcBef>
+                <a:spcPts val="0"/>
+              </a:spcBef>
+              <a:spcAft>
+                <a:spcPts val="0"/>
+              </a:spcAft>
+              <a:buNone/>
+            </a:pPr>
+            <a:r>
+              <a:rPr lang="en"/>
+              <a:t>VO / SFX</a:t>
+            </a:r>
+            <a:endParaRPr/>
+          </a:p>
+        </p:txBody>
+      </p:sp>
+      <p:sp>
+        <p:nvSpPr>
+          <p:cNvPr id="70" name="P3_SHOT_SIZE"/>
+          <p:cNvSpPr/>
+          <p:nvPr/>
+        </p:nvSpPr>
+        <p:spPr>
+          <a:xfrm>
+            <a:off x="6027488" y="2096925"/>
+            <a:ext cx="2697000" cy="288600"/>
+          </a:xfrm>
+          <a:prstGeom prst="rect">
+            <a:avLst/>
+          </a:prstGeom>
+          <a:solidFill>
+            <a:schemeClr val="lt2"/>
+          </a:solidFill>
+          <a:ln cap="flat" cmpd="sng" w="9525">
+            <a:solidFill>
+              <a:schemeClr val="dk2"/>
+            </a:solidFill>
+            <a:prstDash val="solid"/>
+            <a:round/>
+            <a:headEnd len="sm" w="sm" type="none"/>
+            <a:tailEnd len="sm" w="sm" type="none"/>
+          </a:ln>
+        </p:spPr>
+        <p:txBody>
+          <a:bodyPr anchorCtr="0" anchor="ctr" bIns="91425" lIns="91425" spcFirstLastPara="1" rIns="91425" wrap="square" tIns="91425">
+            <a:noAutofit/>
+          </a:bodyPr>
+          <a:lstStyle/>
+          <a:p>
+            <a:pPr indent="0" lvl="0" marL="0" rtl="0" algn="ctr">
+              <a:spcBef>
+                <a:spcPts val="0"/>
+              </a:spcBef>
+              <a:spcAft>
+                <a:spcPts val="0"/>
+              </a:spcAft>
+              <a:buNone/>
+            </a:pPr>
+            <a:r>
+              <a:rPr lang="en"/>
+              <a:t>SHOT SIZE</a:t>
+            </a:r>
+            <a:endParaRPr/>
+          </a:p>
+        </p:txBody>
+      </p:sp>
+      <p:sp>
+        <p:nvSpPr>
+          <p:cNvPr id="71" name="P3_SHOT_DESCRIPTION"/>
+          <p:cNvSpPr/>
+          <p:nvPr/>
+        </p:nvSpPr>
+        <p:spPr>
+          <a:xfrm>
+            <a:off x="6027463" y="2465400"/>
+            <a:ext cx="2697000" cy="1014300"/>
+          </a:xfrm>
+          <a:prstGeom prst="rect">
+            <a:avLst/>
+          </a:prstGeom>
+          <a:solidFill>
+            <a:schemeClr val="lt2"/>
+          </a:solidFill>
+          <a:ln cap="flat" cmpd="sng" w="9525">
+            <a:solidFill>
+              <a:schemeClr val="dk2"/>
+            </a:solidFill>
+            <a:prstDash val="solid"/>
+            <a:round/>
+            <a:headEnd len="sm" w="sm" type="none"/>
+            <a:tailEnd len="sm" w="sm" type="none"/>
+          </a:ln>
+        </p:spPr>
+        <p:txBody>
+          <a:bodyPr anchorCtr="0" anchor="ctr" bIns="91425" lIns="91425" spcFirstLastPara="1" rIns="91425" wrap="square" tIns="91425">
+            <a:noAutofit/>
+          </a:bodyPr>
+          <a:lstStyle/>
+          <a:p>
+            <a:pPr indent="0" lvl="0" marL="0" rtl="0" algn="ctr">
+              <a:spcBef>
+                <a:spcPts val="0"/>
+              </a:spcBef>
+              <a:spcAft>
+                <a:spcPts val="0"/>
+              </a:spcAft>
+              <a:buNone/>
+            </a:pPr>
+            <a:r>
+              <a:rPr lang="en"/>
+              <a:t>SHOT DESCRIPTION</a:t>
+            </a:r>
+            <a:endParaRPr/>
+          </a:p>
+        </p:txBody>
+      </p:sp>
+      <p:sp>
+        <p:nvSpPr>
+          <p:cNvPr id="72" name="P3_SUPERS"/>
+          <p:cNvSpPr/>
+          <p:nvPr/>
+        </p:nvSpPr>
+        <p:spPr>
+          <a:xfrm>
+            <a:off x="6027463" y="3559575"/>
+            <a:ext cx="2697000" cy="288600"/>
+          </a:xfrm>
+          <a:prstGeom prst="rect">
+            <a:avLst/>
+          </a:prstGeom>
+          <a:solidFill>
+            <a:schemeClr val="lt2"/>
+          </a:solidFill>
+          <a:ln cap="flat" cmpd="sng" w="9525">
+            <a:solidFill>
+              <a:schemeClr val="dk2"/>
+            </a:solidFill>
+            <a:prstDash val="solid"/>
+            <a:round/>
+            <a:headEnd len="sm" w="sm" type="none"/>
+            <a:tailEnd len="sm" w="sm" type="none"/>
+          </a:ln>
+        </p:spPr>
+        <p:txBody>
+          <a:bodyPr anchorCtr="0" anchor="ctr" bIns="91425" lIns="91425" spcFirstLastPara="1" rIns="91425" wrap="square" tIns="91425">
+            <a:noAutofit/>
+          </a:bodyPr>
+          <a:lstStyle/>
+          <a:p>
+            <a:pPr indent="0" lvl="0" marL="0" rtl="0" algn="ctr">
+              <a:spcBef>
+                <a:spcPts val="0"/>
+              </a:spcBef>
+              <a:spcAft>
+                <a:spcPts val="0"/>
+              </a:spcAft>
+              <a:buNone/>
+            </a:pPr>
+            <a:r>
+              <a:rPr lang="en"/>
+              <a:t>SUPERS</a:t>
+            </a:r>
+            <a:endParaRPr/>
+          </a:p>
+        </p:txBody>
+      </p:sp>
+      <p:sp>
+        <p:nvSpPr>
+          <p:cNvPr id="73" name="P3_LOWER_3RD"/>
+          <p:cNvSpPr/>
+          <p:nvPr/>
+        </p:nvSpPr>
+        <p:spPr>
+          <a:xfrm>
+            <a:off x="6027463" y="3928050"/>
+            <a:ext cx="2697000" cy="288600"/>
+          </a:xfrm>
+          <a:prstGeom prst="rect">
+            <a:avLst/>
+          </a:prstGeom>
+          <a:solidFill>
+            <a:schemeClr val="lt2"/>
+          </a:solidFill>
+          <a:ln cap="flat" cmpd="sng" w="9525">
+            <a:solidFill>
+              <a:schemeClr val="dk2"/>
+            </a:solidFill>
+            <a:prstDash val="solid"/>
+            <a:round/>
+            <a:headEnd len="sm" w="sm" type="none"/>
+            <a:tailEnd len="sm" w="sm" type="none"/>
+          </a:ln>
+        </p:spPr>
+        <p:txBody>
+          <a:bodyPr anchorCtr="0" anchor="ctr" bIns="91425" lIns="91425" spcFirstLastPara="1" rIns="91425" wrap="square" tIns="91425">
+            <a:noAutofit/>
+          </a:bodyPr>
+          <a:lstStyle/>
+          <a:p>
+            <a:pPr indent="0" lvl="0" marL="0" rtl="0" algn="ctr">
+              <a:spcBef>
+                <a:spcPts val="0"/>
+              </a:spcBef>
+              <a:spcAft>
+                <a:spcPts val="0"/>
+              </a:spcAft>
+              <a:buNone/>
+            </a:pPr>
+            <a:r>
+              <a:rPr lang="en"/>
+              <a:t>LOWER 3RD</a:t>
+            </a:r>
+            <a:endParaRPr/>
+          </a:p>
+        </p:txBody>
+      </p:sp>
+      <p:sp>
+        <p:nvSpPr>
+          <p:cNvPr id="74" name="P3_VO_SFX"/>
+          <p:cNvSpPr/>
+          <p:nvPr/>
+        </p:nvSpPr>
+        <p:spPr>
+          <a:xfrm>
+            <a:off x="6027463" y="4296525"/>
+            <a:ext cx="2697000" cy="288600"/>
+          </a:xfrm>
+          <a:prstGeom prst="rect">
+            <a:avLst/>
+          </a:prstGeom>
+          <a:solidFill>
+            <a:schemeClr val="lt2"/>
+          </a:solidFill>
+          <a:ln cap="flat" cmpd="sng" w="9525">
+            <a:solidFill>
+              <a:schemeClr val="dk2"/>
+            </a:solidFill>
+            <a:prstDash val="solid"/>
+            <a:round/>
+            <a:headEnd len="sm" w="sm" type="none"/>
+            <a:tailEnd len="sm" w="sm" type="none"/>
+          </a:ln>
+        </p:spPr>
+        <p:txBody>
+          <a:bodyPr anchorCtr="0" anchor="ctr" bIns="91425" lIns="91425" spcFirstLastPara="1" rIns="91425" wrap="square" tIns="91425">
+            <a:noAutofit/>
+          </a:bodyPr>
+          <a:lstStyle/>
+          <a:p>
+            <a:pPr indent="0" lvl="0" marL="0" rtl="0" algn="ctr">
+              <a:spcBef>
+                <a:spcPts val="0"/>
+              </a:spcBef>
+              <a:spcAft>
+                <a:spcPts val="0"/>
+              </a:spcAft>
+              <a:buNone/>
+            </a:pPr>
+            <a:r>
+              <a:rPr lang="en"/>
+              <a:t>VO / SFX</a:t>
+            </a:r>
+            <a:endParaRPr/>
           </a:p>
         </p:txBody>
       </p:sp>

</xml_diff>